<commit_message>
docs: describe the provider-agnostic WebSocket voice pipeline
Several docs still described the retired WebRTC/Opus/DataChannel path and
implied voice was OpenAI-only. Correct them to match the shipped code:
WebSocket PCM16 audio, provider selection by config, and the two
implemented providers (Gemini Live and OpenAI Realtime-compatible).

Also regenerate the PDFs and the presentation deck from the updated
HTML and slide sources, and drop the <300ms latency claim that was never
measured.

Co-Authored-By: Claude Code <noreply@anthropic.com>
</commit_message>
<xml_diff>
--- a/docs/BrightSmile_Dental_AI_Presentation.pptx
+++ b/docs/BrightSmile_Dental_AI_Presentation.pptx
@@ -1828,7 +1828,7 @@
                 <a:ea typeface="Arial" pitchFamily="34" charset="-122"/>
                 <a:cs typeface="Arial" pitchFamily="34" charset="-120"/>
               </a:rPr>
-              <a:t>Real-Time WebRTC Voice</a:t>
+              <a:t>Realtime Streaming Voice</a:t>
             </a:r>
             <a:endParaRPr lang="en-US" sz="1150" dirty="0"/>
           </a:p>
@@ -1867,7 +1867,7 @@
                 <a:ea typeface="Arial" pitchFamily="34" charset="-122"/>
                 <a:cs typeface="Arial" pitchFamily="34" charset="-120"/>
               </a:rPr>
-              <a:t>Natural human-like voice with &lt;300ms latency &amp; zero master key leaks</a:t>
+              <a:t>Natural human-like voice over WebSocket, provider-agnostic &amp; zero master key leaks</a:t>
             </a:r>
             <a:endParaRPr lang="en-US" sz="850" dirty="0"/>
           </a:p>
@@ -2888,7 +2888,7 @@
                 <a:ea typeface="Arial" pitchFamily="34" charset="-122"/>
                 <a:cs typeface="Arial" pitchFamily="34" charset="-120"/>
               </a:rPr>
-              <a:t>Patients book anytime via spoken voice calls (WebRTC) or instant chat.</a:t>
+              <a:t>Patients book anytime via spoken voice calls (streaming WebSocket) or instant chat.</a:t>
             </a:r>
             <a:endParaRPr lang="en-US" sz="950" dirty="0"/>
           </a:p>
@@ -4013,7 +4013,7 @@
                 <a:ea typeface="Arial" pitchFamily="34" charset="-122"/>
                 <a:cs typeface="Arial" pitchFamily="34" charset="-120"/>
               </a:rPr>
-              <a:t>Patient speaks via WebRTC audio (Opus) or sends message via Next.js chat portal.</a:t>
+              <a:t>Patient speaks via streaming PCM audio over WebSocket, or sends a message via the Next.js chat portal.</a:t>
             </a:r>
             <a:endParaRPr lang="en-US" sz="800" dirty="0"/>
           </a:p>
@@ -4611,7 +4611,7 @@
                 <a:ea typeface="Arial" pitchFamily="34" charset="-122"/>
                 <a:cs typeface="Arial" pitchFamily="34" charset="-120"/>
               </a:rPr>
-              <a:t>Issues &lt;60s ephemeral secrets. Routes tool executions via WebRTC DataChannel.</a:t>
+              <a:t>Selects the configured voice provider and returns its session descriptor. Tool calls are executed server-side.</a:t>
             </a:r>
             <a:endParaRPr lang="en-US" sz="800" dirty="0"/>
           </a:p>
@@ -5314,7 +5314,7 @@
                 <a:ea typeface="Arial" pitchFamily="34" charset="-122"/>
                 <a:cs typeface="Arial" pitchFamily="34" charset="-120"/>
               </a:rPr>
-              <a:t>1. Ephemeral Secret Isolation
+              <a:t>1. Server-Owned Voice Session
 </a:t>
             </a:r>
             <a:pPr indent="0" marL="0">
@@ -5329,7 +5329,7 @@
                 <a:ea typeface="Arial" pitchFamily="34" charset="-122"/>
                 <a:cs typeface="Arial" pitchFamily="34" charset="-120"/>
               </a:rPr>
-              <a:t>Master OpenAI keys never touch the browser. Short-lived tokens expire in &lt;60 seconds.</a:t>
+              <a:t>Master provider keys never touch the browser. The server returns only a session descriptor with the role and tools it granted.</a:t>
             </a:r>
             <a:endParaRPr lang="en-US" sz="900" dirty="0"/>
           </a:p>
@@ -8262,7 +8262,7 @@
                 <a:ea typeface="Arial" pitchFamily="34" charset="-122"/>
                 <a:cs typeface="Arial" pitchFamily="34" charset="-120"/>
               </a:rPr>
-              <a:t>CONVERSATIONAL VOICE AI &amp; WEBRTC FLOW</a:t>
+              <a:t>CONVERSATIONAL VOICE AI &amp; WEBSOCKET FLOW</a:t>
             </a:r>
             <a:endParaRPr lang="en-US" sz="1000" dirty="0"/>
           </a:p>
@@ -8301,7 +8301,7 @@
                 <a:ea typeface="Arial" pitchFamily="34" charset="-122"/>
                 <a:cs typeface="Arial" pitchFamily="34" charset="-120"/>
               </a:rPr>
-              <a:t>Low-Latency WebRTC Voice Architecture (&lt;300ms)</a:t>
+              <a:t>Provider-Agnostic Streaming Voice Architecture</a:t>
             </a:r>
             <a:endParaRPr lang="en-US" sz="2000" dirty="0"/>
           </a:p>
@@ -8340,7 +8340,7 @@
                 <a:ea typeface="Arial" pitchFamily="34" charset="-122"/>
                 <a:cs typeface="Arial" pitchFamily="34" charset="-120"/>
               </a:rPr>
-              <a:t>How patient voice streams directly to the AI engine while clinical tool calls are verified safely on the backend.</a:t>
+              <a:t>How patient voice streams over WebSocket to the configured realtime provider while clinical tool calls are verified safely on the backend.</a:t>
             </a:r>
             <a:endParaRPr lang="en-US" sz="1100" dirty="0"/>
           </a:p>
@@ -8472,7 +8472,7 @@
                 <a:ea typeface="Arial" pitchFamily="34" charset="-122"/>
                 <a:cs typeface="Arial" pitchFamily="34" charset="-120"/>
               </a:rPr>
-              <a:t>POST /api/v1/voice/session</a:t>
+              <a:t>GET /api/v1/voice/session</a:t>
             </a:r>
             <a:endParaRPr lang="en-US" sz="800" dirty="0"/>
           </a:p>
@@ -8511,7 +8511,7 @@
                 <a:ea typeface="Arial" pitchFamily="34" charset="-122"/>
                 <a:cs typeface="Arial" pitchFamily="34" charset="-120"/>
               </a:rPr>
-              <a:t>Ephemeral Token Gate</a:t>
+              <a:t>Provider Session Gate</a:t>
             </a:r>
             <a:endParaRPr lang="en-US" sz="1300" dirty="0"/>
           </a:p>
@@ -8573,7 +8573,7 @@
                 <a:ea typeface="Arial" pitchFamily="34" charset="-122"/>
                 <a:cs typeface="Arial" pitchFamily="34" charset="-120"/>
               </a:rPr>
-              <a:t>Client browser requests a temporary session token. Next.js server calls OpenAI to generate an ephemeral client secret with &lt;60s expiry.</a:t>
+              <a:t>Server picks the configured voice provider and returns its session descriptor: a single-use Gemini token, or a direct endpoint URL when an OpenAI-compatible server is configured.</a:t>
             </a:r>
             <a:endParaRPr lang="en-US" sz="850" dirty="0"/>
           </a:p>
@@ -8837,7 +8837,7 @@
                 <a:ea typeface="Arial" pitchFamily="34" charset="-122"/>
                 <a:cs typeface="Arial" pitchFamily="34" charset="-120"/>
               </a:rPr>
-              <a:t>PeerConnection (Opus Audio)</a:t>
+              <a:t>WebSocket (PCM16 16/24 kHz)</a:t>
             </a:r>
             <a:endParaRPr lang="en-US" sz="800" dirty="0"/>
           </a:p>
@@ -8876,7 +8876,7 @@
                 <a:ea typeface="Arial" pitchFamily="34" charset="-122"/>
                 <a:cs typeface="Arial" pitchFamily="34" charset="-120"/>
               </a:rPr>
-              <a:t>Direct WebRTC Audio</a:t>
+              <a:t>Streaming WebSocket Audio</a:t>
             </a:r>
             <a:endParaRPr lang="en-US" sz="1300" dirty="0"/>
           </a:p>
@@ -8938,7 +8938,7 @@
                 <a:ea typeface="Arial" pitchFamily="34" charset="-122"/>
                 <a:cs typeface="Arial" pitchFamily="34" charset="-120"/>
               </a:rPr>
-              <a:t>Browser establishes direct full-duplex WebRTC audio connection to OpenAI Realtime. Provides human-like speech with immediate interruption capability.</a:t>
+              <a:t>Browser streams base64 PCM audio over a WebSocket to the realtime provider in both directions. Full-duplex audio with immediate interruption handling.</a:t>
             </a:r>
             <a:endParaRPr lang="en-US" sz="850" dirty="0"/>
           </a:p>
@@ -9004,7 +9004,7 @@
                 <a:ea typeface="Arial" pitchFamily="34" charset="-122"/>
                 <a:cs typeface="Arial" pitchFamily="34" charset="-120"/>
               </a:rPr>
-              <a:t>&lt;300ms LATENCY</a:t>
+              <a:t>PROVIDER-AGNOSTIC</a:t>
             </a:r>
             <a:endParaRPr lang="en-US" sz="750" dirty="0"/>
           </a:p>
@@ -9303,7 +9303,7 @@
                 <a:ea typeface="Arial" pitchFamily="34" charset="-122"/>
                 <a:cs typeface="Arial" pitchFamily="34" charset="-120"/>
               </a:rPr>
-              <a:t>When patient confirms a slot, function calling triggers over WebRTC DataChannel. The backend validates doctor qualification and writes to the DB.</a:t>
+              <a:t>When the patient confirms a slot, the provider emits a tool call that the browser relays to the server. The backend validates doctor qualification and writes to the DB.</a:t>
             </a:r>
             <a:endParaRPr lang="en-US" sz="850" dirty="0"/>
           </a:p>
@@ -9536,7 +9536,7 @@
                 <a:ea typeface="Arial" pitchFamily="34" charset="-122"/>
                 <a:cs typeface="Arial" pitchFamily="34" charset="-120"/>
               </a:rPr>
-              <a:t>BRIGHTSMILE WEBRTC ENGINE (&lt;300ms Delay)</a:t>
+              <a:t>BRIGHTSMILE STREAMING ENGINE</a:t>
             </a:r>
             <a:endParaRPr lang="en-US" sz="900" dirty="0"/>
           </a:p>
@@ -11298,7 +11298,7 @@
                           <a:ea typeface="Arial" pitchFamily="34" charset="-122"/>
                           <a:cs typeface="Arial" pitchFamily="34" charset="-120"/>
                         </a:rPr>
-                        <a:t>Voice AI (OpenAI Realtime)</a:t>
+                        <a:t>Voice AI (Realtime, illustrative)</a:t>
                       </a:r>
                       <a:endParaRPr lang="en-US" sz="850" dirty="0">
                         <a:latin typeface="Arial" charset="0"/>

</xml_diff>